<commit_message>
Update CIX Project Slides
</commit_message>
<xml_diff>
--- a/assets/CIX Project Slides.pptx
+++ b/assets/CIX Project Slides.pptx
@@ -241,6 +241,11 @@
       </a:defRPr>
     </a:lvl9pPr>
   </p:defaultTextStyle>
+  <p:extLst>
+    <p:ext uri="{EFAFB233-063F-42B5-8137-9DF3F51BA10A}">
+      <p15:sldGuideLst xmlns:p15="http://schemas.microsoft.com/office/powerpoint/2012/main"/>
+    </p:ext>
+  </p:extLst>
 </p:presentation>
 </file>
 
@@ -2523,6 +2528,18 @@
               <a:buNone/>
             </a:pPr>
             <a:r>
+              <a:rPr lang="en-US" sz="1500" b="0" i="0" u="none" strike="noStrike" cap="none" dirty="0">
+                <a:solidFill>
+                  <a:srgbClr val="CADCFC"/>
+                </a:solidFill>
+                <a:latin typeface="Calibri"/>
+                <a:ea typeface="Calibri"/>
+                <a:cs typeface="Calibri"/>
+                <a:sym typeface="Calibri"/>
+              </a:rPr>
+              <a:t>Analytics Consulting Project  ·  Client: Fortune 500 Medical </a:t>
+            </a:r>
+            <a:r>
               <a:rPr lang="en-US" sz="1500" b="0" i="0" u="none" strike="noStrike" cap="none">
                 <a:solidFill>
                   <a:srgbClr val="CADCFC"/>
@@ -2532,9 +2549,9 @@
                 <a:cs typeface="Calibri"/>
                 <a:sym typeface="Calibri"/>
               </a:rPr>
-              <a:t>Analytics Consulting Project  ·  Client: Fortune 500 Medical Device Manufacturer (name confidential per NDA)</a:t>
+              <a:t>Device Manufacturer</a:t>
             </a:r>
-            <a:endParaRPr sz="1500" b="0" i="0" u="none" strike="noStrike" cap="none">
+            <a:endParaRPr sz="1500" b="0" i="0" u="none" strike="noStrike" cap="none" dirty="0">
               <a:solidFill>
                 <a:schemeClr val="dk1"/>
               </a:solidFill>

</xml_diff>